<commit_message>
Refine investor-safe wording in token distribution deck and refresh 3rd document slides
</commit_message>
<xml_diff>
--- a/investor-materials/token_distribution_linkedin.pptx
+++ b/investor-materials/token_distribution_linkedin.pptx
@@ -3465,15 +3465,15 @@
             </a:pPr>
             <a:r>
               <a:rPr sz="2000" dirty="0"/>
-              <a:t>70% queries </a:t>
+              <a:t>A majority of queries are handled locally, minimizing cloud dependency.</a:t>
             </a:r>
             <a:r>
               <a:rPr lang="en-IN" sz="2000" dirty="0"/>
-              <a:t>On-Device Execution Tier </a:t>
+              <a:t/>
             </a:r>
             <a:r>
               <a:rPr sz="2000" dirty="0"/>
-              <a:t>run for free (no cloud cost).</a:t>
+              <a:t/>
             </a:r>
           </a:p>
           <a:p>
@@ -3492,15 +3492,15 @@
             </a:pPr>
             <a:r>
               <a:rPr sz="2000" dirty="0"/>
-              <a:t>20-25% mid-token queries handled by </a:t>
+              <a:t>Mid-range workloads are processed through optimized infrastructure for efficiency.</a:t>
             </a:r>
             <a:r>
               <a:rPr lang="en-IN" sz="2000" dirty="0"/>
-              <a:t>Regional Optimized Tier </a:t>
+              <a:t/>
             </a:r>
             <a:r>
               <a:rPr sz="2000" dirty="0"/>
-              <a:t>at &lt;$0.002/query.</a:t>
+              <a:t/>
             </a:r>
           </a:p>
           <a:p>
@@ -3822,28 +3822,8 @@
           </a:bodyPr>
           <a:lstStyle/>
           <a:p>
-            <a:pPr algn="ctr">
-              <a:defRPr sz="1400">
-                <a:solidFill>
-                  <a:srgbClr val="FFFFFF"/>
-                </a:solidFill>
-                <a:latin typeface="Segoe UI"/>
-              </a:defRPr>
-            </a:pPr>
             <a:r>
-              <a:rPr lang="en-IN" dirty="0"/>
-              <a:t>On-Device Execution Tier</a:t>
-            </a:r>
-            <a:r>
-              <a:rPr dirty="0"/>
-              <a:t> &lt;=400 tokens</a:t>
-            </a:r>
-            <a:br>
-              <a:rPr dirty="0"/>
-            </a:br>
-            <a:r>
-              <a:rPr dirty="0"/>
-              <a:t>~70% queries</a:t>
+              <a:t>Common queries handled locally</a:t>
             </a:r>
           </a:p>
         </p:txBody>
@@ -3870,28 +3850,8 @@
           </a:bodyPr>
           <a:lstStyle/>
           <a:p>
-            <a:pPr algn="ctr">
-              <a:defRPr sz="1200">
-                <a:solidFill>
-                  <a:srgbClr val="FFFFFF"/>
-                </a:solidFill>
-                <a:latin typeface="Segoe UI"/>
-              </a:defRPr>
-            </a:pPr>
             <a:r>
-              <a:rPr lang="en-IN" sz="1200" dirty="0"/>
-              <a:t>Regional Optimized Tier </a:t>
-            </a:r>
-            <a:r>
-              <a:rPr dirty="0"/>
-              <a:t>400-1000 tokens</a:t>
-            </a:r>
-            <a:br>
-              <a:rPr dirty="0"/>
-            </a:br>
-            <a:r>
-              <a:rPr dirty="0"/>
-              <a:t>~20-25% queries</a:t>
+              <a:t>Moderate workloads processed efficiently</a:t>
             </a:r>
           </a:p>
         </p:txBody>
@@ -3918,24 +3878,8 @@
           </a:bodyPr>
           <a:lstStyle/>
           <a:p>
-            <a:pPr algn="ctr">
-              <a:defRPr sz="1200">
-                <a:solidFill>
-                  <a:srgbClr val="FFFFFF"/>
-                </a:solidFill>
-                <a:latin typeface="Segoe UI"/>
-              </a:defRPr>
-            </a:pPr>
             <a:r>
-              <a:rPr dirty="0"/>
-              <a:t>LLM &gt;=1000</a:t>
-            </a:r>
-            <a:br>
-              <a:rPr dirty="0"/>
-            </a:br>
-            <a:r>
-              <a:rPr dirty="0"/>
-              <a:t>~5-10%</a:t>
+              <a:t>Complex tasks requiring advanced reasoning</a:t>
             </a:r>
           </a:p>
         </p:txBody>
@@ -10501,7 +10445,7 @@
               </a:defRPr>
             </a:pPr>
             <a:r>
-              <a:t>Only 5-10% of queries pay full GPU tax</a:t>
+              <a:t>Only a small portion of queries require full GPU compute</a:t>
             </a:r>
           </a:p>
           <a:p>

</xml_diff>

<commit_message>
Tighten token band label text to avoid overflow in slide chart
</commit_message>
<xml_diff>
--- a/investor-materials/token_distribution_linkedin.pptx
+++ b/investor-materials/token_distribution_linkedin.pptx
@@ -3851,7 +3851,12 @@
           <a:lstStyle/>
           <a:p>
             <a:r>
-              <a:t>Moderate workloads processed efficiently</a:t>
+              <a:t>Moderate workloads</a:t>
+            </a:r>
+          </a:p>
+          <a:p>
+            <a:r>
+              <a:t>processed efficiently</a:t>
             </a:r>
           </a:p>
         </p:txBody>
@@ -3879,7 +3884,12 @@
           <a:lstStyle/>
           <a:p>
             <a:r>
-              <a:t>Complex tasks requiring advanced reasoning</a:t>
+              <a:t>Complex tasks</a:t>
+            </a:r>
+          </a:p>
+          <a:p>
+            <a:r>
+              <a:t>advanced reasoning</a:t>
             </a:r>
           </a:p>
         </p:txBody>

</xml_diff>

<commit_message>
Add Medium blog links to all footers and tighten token-band bar labels
</commit_message>
<xml_diff>
--- a/investor-materials/token_distribution_linkedin.pptx
+++ b/investor-materials/token_distribution_linkedin.pptx
@@ -3854,11 +3854,6 @@
               <a:t>Moderate workloads</a:t>
             </a:r>
           </a:p>
-          <a:p>
-            <a:r>
-              <a:t>processed efficiently</a:t>
-            </a:r>
-          </a:p>
         </p:txBody>
       </p:sp>
       <p:sp>
@@ -3885,11 +3880,6 @@
           <a:p>
             <a:r>
               <a:t>Complex tasks</a:t>
-            </a:r>
-          </a:p>
-          <a:p>
-            <a:r>
-              <a:t>advanced reasoning</a:t>
             </a:r>
           </a:p>
         </p:txBody>

</xml_diff>

<commit_message>
Update token-band bar labels to Edge/Cloud CPU/LLM and refresh document slides
</commit_message>
<xml_diff>
--- a/investor-materials/token_distribution_linkedin.pptx
+++ b/investor-materials/token_distribution_linkedin.pptx
@@ -3823,7 +3823,7 @@
           <a:lstStyle/>
           <a:p>
             <a:r>
-              <a:t>Common queries handled locally</a:t>
+              <a:t>Edge (Local)</a:t>
             </a:r>
           </a:p>
         </p:txBody>
@@ -3851,7 +3851,7 @@
           <a:lstStyle/>
           <a:p>
             <a:r>
-              <a:t>Moderate workloads</a:t>
+              <a:t>Cloud CPU</a:t>
             </a:r>
           </a:p>
         </p:txBody>
@@ -3879,7 +3879,7 @@
           <a:lstStyle/>
           <a:p>
             <a:r>
-              <a:t>Complex tasks</a:t>
+              <a:t>LLM</a:t>
             </a:r>
           </a:p>
         </p:txBody>

</xml_diff>